<commit_message>
Last version after some modifs in class
</commit_message>
<xml_diff>
--- a/01R/00_program.pptx
+++ b/01R/00_program.pptx
@@ -266,7 +266,7 @@
           <a:p>
             <a:fld id="{4EE964EE-54EA-C548-83C6-1EDF183EC8D4}" type="datetimeFigureOut">
               <a:rPr lang="fr-FR" smtClean="0"/>
-              <a:t>27/05/2025</a:t>
+              <a:t>31/05/2025</a:t>
             </a:fld>
             <a:endParaRPr lang="fr-FR"/>
           </a:p>
@@ -464,7 +464,7 @@
           <a:p>
             <a:fld id="{4EE964EE-54EA-C548-83C6-1EDF183EC8D4}" type="datetimeFigureOut">
               <a:rPr lang="fr-FR" smtClean="0"/>
-              <a:t>27/05/2025</a:t>
+              <a:t>31/05/2025</a:t>
             </a:fld>
             <a:endParaRPr lang="fr-FR"/>
           </a:p>
@@ -672,7 +672,7 @@
           <a:p>
             <a:fld id="{4EE964EE-54EA-C548-83C6-1EDF183EC8D4}" type="datetimeFigureOut">
               <a:rPr lang="fr-FR" smtClean="0"/>
-              <a:t>27/05/2025</a:t>
+              <a:t>31/05/2025</a:t>
             </a:fld>
             <a:endParaRPr lang="fr-FR"/>
           </a:p>
@@ -870,7 +870,7 @@
           <a:p>
             <a:fld id="{4EE964EE-54EA-C548-83C6-1EDF183EC8D4}" type="datetimeFigureOut">
               <a:rPr lang="fr-FR" smtClean="0"/>
-              <a:t>27/05/2025</a:t>
+              <a:t>31/05/2025</a:t>
             </a:fld>
             <a:endParaRPr lang="fr-FR"/>
           </a:p>
@@ -1145,7 +1145,7 @@
           <a:p>
             <a:fld id="{4EE964EE-54EA-C548-83C6-1EDF183EC8D4}" type="datetimeFigureOut">
               <a:rPr lang="fr-FR" smtClean="0"/>
-              <a:t>27/05/2025</a:t>
+              <a:t>31/05/2025</a:t>
             </a:fld>
             <a:endParaRPr lang="fr-FR"/>
           </a:p>
@@ -1410,7 +1410,7 @@
           <a:p>
             <a:fld id="{4EE964EE-54EA-C548-83C6-1EDF183EC8D4}" type="datetimeFigureOut">
               <a:rPr lang="fr-FR" smtClean="0"/>
-              <a:t>27/05/2025</a:t>
+              <a:t>31/05/2025</a:t>
             </a:fld>
             <a:endParaRPr lang="fr-FR"/>
           </a:p>
@@ -1822,7 +1822,7 @@
           <a:p>
             <a:fld id="{4EE964EE-54EA-C548-83C6-1EDF183EC8D4}" type="datetimeFigureOut">
               <a:rPr lang="fr-FR" smtClean="0"/>
-              <a:t>27/05/2025</a:t>
+              <a:t>31/05/2025</a:t>
             </a:fld>
             <a:endParaRPr lang="fr-FR"/>
           </a:p>
@@ -1963,7 +1963,7 @@
           <a:p>
             <a:fld id="{4EE964EE-54EA-C548-83C6-1EDF183EC8D4}" type="datetimeFigureOut">
               <a:rPr lang="fr-FR" smtClean="0"/>
-              <a:t>27/05/2025</a:t>
+              <a:t>31/05/2025</a:t>
             </a:fld>
             <a:endParaRPr lang="fr-FR"/>
           </a:p>
@@ -2076,7 +2076,7 @@
           <a:p>
             <a:fld id="{4EE964EE-54EA-C548-83C6-1EDF183EC8D4}" type="datetimeFigureOut">
               <a:rPr lang="fr-FR" smtClean="0"/>
-              <a:t>27/05/2025</a:t>
+              <a:t>31/05/2025</a:t>
             </a:fld>
             <a:endParaRPr lang="fr-FR"/>
           </a:p>
@@ -2387,7 +2387,7 @@
           <a:p>
             <a:fld id="{4EE964EE-54EA-C548-83C6-1EDF183EC8D4}" type="datetimeFigureOut">
               <a:rPr lang="fr-FR" smtClean="0"/>
-              <a:t>27/05/2025</a:t>
+              <a:t>31/05/2025</a:t>
             </a:fld>
             <a:endParaRPr lang="fr-FR"/>
           </a:p>
@@ -2675,7 +2675,7 @@
           <a:p>
             <a:fld id="{4EE964EE-54EA-C548-83C6-1EDF183EC8D4}" type="datetimeFigureOut">
               <a:rPr lang="fr-FR" smtClean="0"/>
-              <a:t>27/05/2025</a:t>
+              <a:t>31/05/2025</a:t>
             </a:fld>
             <a:endParaRPr lang="fr-FR"/>
           </a:p>
@@ -2916,7 +2916,7 @@
           <a:p>
             <a:fld id="{4EE964EE-54EA-C548-83C6-1EDF183EC8D4}" type="datetimeFigureOut">
               <a:rPr lang="fr-FR" smtClean="0"/>
-              <a:t>27/05/2025</a:t>
+              <a:t>31/05/2025</a:t>
             </a:fld>
             <a:endParaRPr lang="fr-FR"/>
           </a:p>
@@ -3954,7 +3954,7 @@
         <p:spPr/>
         <p:txBody>
           <a:bodyPr>
-            <a:normAutofit lnSpcReduction="10000"/>
+            <a:normAutofit/>
           </a:bodyPr>
           <a:lstStyle/>
           <a:p>
@@ -3963,10 +3963,6 @@
               <a:rPr lang="en-US" noProof="0" dirty="0"/>
               <a:t>Scenario: I want to produce a nice figure and a short report for my boss.</a:t>
             </a:r>
-            <a:br>
-              <a:rPr lang="en-US" noProof="0" dirty="0"/>
-            </a:br>
-            <a:endParaRPr lang="en-US" noProof="0" dirty="0"/>
           </a:p>
           <a:p>
             <a:pPr algn="just"/>
@@ -3982,6 +3978,11 @@
               <a:rPr lang="en-US" noProof="0" dirty="0"/>
               <a:t>”… let’s take a look!</a:t>
             </a:r>
+            <a:endParaRPr lang="en-US" dirty="0"/>
+          </a:p>
+          <a:p>
+            <a:pPr algn="just"/>
+            <a:endParaRPr lang="en-US" noProof="0" dirty="0"/>
           </a:p>
           <a:p>
             <a:pPr algn="just"/>
@@ -4001,17 +4002,9 @@
           </a:p>
           <a:p>
             <a:pPr algn="just"/>
-            <a:endParaRPr lang="en-US" dirty="0"/>
-          </a:p>
-          <a:p>
-            <a:pPr algn="just"/>
-            <a:endParaRPr lang="en-US" noProof="0" dirty="0"/>
-          </a:p>
-          <a:p>
-            <a:pPr algn="just"/>
             <a:r>
               <a:rPr lang="en-US" noProof="0" dirty="0"/>
-              <a:t>Quiz: which R command would you use to import this data into the environment?</a:t>
+              <a:t>Which R command would you use to import this data into the environment?</a:t>
             </a:r>
           </a:p>
         </p:txBody>
@@ -4070,7 +4063,7 @@
         </p:blipFill>
         <p:spPr>
           <a:xfrm>
-            <a:off x="935858" y="3508449"/>
+            <a:off x="935858" y="3200104"/>
             <a:ext cx="3922614" cy="1600200"/>
           </a:xfrm>
           <a:prstGeom prst="rect">
@@ -4169,7 +4162,7 @@
                                         <p:tgtEl>
                                           <p:spTgt spid="6">
                                             <p:txEl>
-                                              <p:pRg st="8" end="8"/>
+                                              <p:pRg st="7" end="7"/>
                                             </p:txEl>
                                           </p:spTgt>
                                         </p:tgtEl>

</xml_diff>